<commit_message>
Adiciona bloco Fase 2 (IA) na coluna Experiência de Uso do slide
Inclui validação de dados via IA, sugestão de pedidos/consumo com base
no histórico do CNPJ e meta de crescimento sugerida automaticamente em
tela, marcados visualmente como Fase 2 dentro do mesmo card.

Co-Authored-By: Claude Sonnet 5 <noreply@anthropic.com>
Claude-Session: https://claude.ai/code/session_01PFQTEh9nuuYaWSZgAB3Kxe
</commit_message>
<xml_diff>
--- a/apresentacoes/projeto-impulso-slide.pptx
+++ b/apresentacoes/projeto-impulso-slide.pptx
@@ -1882,13 +1882,13 @@
           <a:p>
             <a:pPr marL="177800" indent="-177800">
               <a:spcAft>
-                <a:spcPts val="1000"/>
+                <a:spcPts val="800"/>
               </a:spcAft>
               <a:buSzPct val="100000"/>
               <a:buChar char="▪"/>
             </a:pPr>
             <a:r>
-              <a:rPr lang="en-US" sz="1250" dirty="0">
+              <a:rPr lang="en-US" sz="1150" dirty="0">
                 <a:solidFill>
                   <a:srgbClr val="1B1F3B"/>
                 </a:solidFill>
@@ -1898,18 +1898,18 @@
               </a:rPr>
               <a:t>Interface amistosa</a:t>
             </a:r>
-            <a:endParaRPr lang="en-US" sz="1250" dirty="0"/>
+            <a:endParaRPr lang="en-US" sz="1150" dirty="0"/>
           </a:p>
           <a:p>
             <a:pPr marL="177800" indent="-177800">
               <a:spcAft>
-                <a:spcPts val="1000"/>
+                <a:spcPts val="800"/>
               </a:spcAft>
               <a:buSzPct val="100000"/>
               <a:buChar char="▪"/>
             </a:pPr>
             <a:r>
-              <a:rPr lang="en-US" sz="1250" dirty="0">
+              <a:rPr lang="en-US" sz="1150" dirty="0">
                 <a:solidFill>
                   <a:srgbClr val="1B1F3B"/>
                 </a:solidFill>
@@ -1919,18 +1919,18 @@
               </a:rPr>
               <a:t>Histórico dos últimos períodos em tela única</a:t>
             </a:r>
-            <a:endParaRPr lang="en-US" sz="1250" dirty="0"/>
+            <a:endParaRPr lang="en-US" sz="1150" dirty="0"/>
           </a:p>
           <a:p>
             <a:pPr marL="177800" indent="-177800">
               <a:spcAft>
-                <a:spcPts val="1000"/>
+                <a:spcPts val="800"/>
               </a:spcAft>
               <a:buSzPct val="100000"/>
               <a:buChar char="▪"/>
             </a:pPr>
             <a:r>
-              <a:rPr lang="en-US" sz="1250" dirty="0">
+              <a:rPr lang="en-US" sz="1150" dirty="0">
                 <a:solidFill>
                   <a:srgbClr val="1B1F3B"/>
                 </a:solidFill>
@@ -1940,18 +1940,18 @@
               </a:rPr>
               <a:t>Digitação de pedido mais intuitiva</a:t>
             </a:r>
-            <a:endParaRPr lang="en-US" sz="1250" dirty="0"/>
+            <a:endParaRPr lang="en-US" sz="1150" dirty="0"/>
           </a:p>
           <a:p>
             <a:pPr marL="177800" indent="-177800">
               <a:spcAft>
-                <a:spcPts val="1000"/>
+                <a:spcPts val="800"/>
               </a:spcAft>
               <a:buSzPct val="100000"/>
               <a:buChar char="▪"/>
             </a:pPr>
             <a:r>
-              <a:rPr lang="en-US" sz="1250" dirty="0">
+              <a:rPr lang="en-US" sz="1150" dirty="0">
                 <a:solidFill>
                   <a:srgbClr val="1B1F3B"/>
                 </a:solidFill>
@@ -1961,7 +1961,93 @@
               </a:rPr>
               <a:t>Carga de pedidos mais intuitiva, com simplificações</a:t>
             </a:r>
-            <a:endParaRPr lang="en-US" sz="1250" dirty="0"/>
+            <a:endParaRPr lang="en-US" sz="1150" dirty="0"/>
+          </a:p>
+          <a:p>
+            <a:pPr indent="0" marL="0">
+              <a:spcBef>
+                <a:spcPts val="500"/>
+              </a:spcBef>
+              <a:spcAft>
+                <a:spcPts val="500"/>
+              </a:spcAft>
+              <a:buNone/>
+            </a:pPr>
+            <a:r>
+              <a:rPr lang="en-US" sz="1000" b="1" spc="100" kern="0" dirty="0">
+                <a:solidFill>
+                  <a:srgbClr val="1E2761"/>
+                </a:solidFill>
+                <a:latin typeface="Calibri" pitchFamily="34" charset="0"/>
+                <a:ea typeface="Calibri" pitchFamily="34" charset="-122"/>
+                <a:cs typeface="Calibri" pitchFamily="34" charset="-120"/>
+              </a:rPr>
+              <a:t>FASE 2 · IA</a:t>
+            </a:r>
+            <a:endParaRPr lang="en-US" sz="1150" dirty="0"/>
+          </a:p>
+          <a:p>
+            <a:pPr marL="177800" indent="-177800">
+              <a:spcAft>
+                <a:spcPts val="800"/>
+              </a:spcAft>
+              <a:buSzPct val="100000"/>
+              <a:buChar char="▫"/>
+            </a:pPr>
+            <a:r>
+              <a:rPr lang="en-US" sz="1150" i="1" dirty="0">
+                <a:solidFill>
+                  <a:srgbClr val="5B6489"/>
+                </a:solidFill>
+                <a:latin typeface="Calibri" pitchFamily="34" charset="0"/>
+                <a:ea typeface="Calibri" pitchFamily="34" charset="-122"/>
+                <a:cs typeface="Calibri" pitchFamily="34" charset="-120"/>
+              </a:rPr>
+              <a:t>Validação de dados via IA</a:t>
+            </a:r>
+            <a:endParaRPr lang="en-US" sz="1150" dirty="0"/>
+          </a:p>
+          <a:p>
+            <a:pPr marL="177800" indent="-177800">
+              <a:spcAft>
+                <a:spcPts val="800"/>
+              </a:spcAft>
+              <a:buSzPct val="100000"/>
+              <a:buChar char="▫"/>
+            </a:pPr>
+            <a:r>
+              <a:rPr lang="en-US" sz="1150" i="1" dirty="0">
+                <a:solidFill>
+                  <a:srgbClr val="5B6489"/>
+                </a:solidFill>
+                <a:latin typeface="Calibri" pitchFamily="34" charset="0"/>
+                <a:ea typeface="Calibri" pitchFamily="34" charset="-122"/>
+                <a:cs typeface="Calibri" pitchFamily="34" charset="-120"/>
+              </a:rPr>
+              <a:t>Sugestão de pedidos e consumo por histórico do CNPJ</a:t>
+            </a:r>
+            <a:endParaRPr lang="en-US" sz="1150" dirty="0"/>
+          </a:p>
+          <a:p>
+            <a:pPr marL="177800" indent="-177800">
+              <a:spcAft>
+                <a:spcPts val="800"/>
+              </a:spcAft>
+              <a:buSzPct val="100000"/>
+              <a:buChar char="▫"/>
+            </a:pPr>
+            <a:r>
+              <a:rPr lang="en-US" sz="1150" i="1" dirty="0">
+                <a:solidFill>
+                  <a:srgbClr val="5B6489"/>
+                </a:solidFill>
+                <a:latin typeface="Calibri" pitchFamily="34" charset="0"/>
+                <a:ea typeface="Calibri" pitchFamily="34" charset="-122"/>
+                <a:cs typeface="Calibri" pitchFamily="34" charset="-120"/>
+              </a:rPr>
+              <a:t>Meta de crescimento (%) sugerida em tela</a:t>
+            </a:r>
+            <a:endParaRPr lang="en-US" sz="1150" dirty="0"/>
           </a:p>
         </p:txBody>
       </p:sp>

</xml_diff>